<commit_message>
Fix SMTP credentials and clean test scripts
</commit_message>
<xml_diff>
--- a/MEMOIRE/La finalisima present_V10.pptx
+++ b/MEMOIRE/La finalisima present_V10.pptx
@@ -123,7 +123,7 @@
 <file path=ppt/revisionInfo.xml><?xml version="1.0" encoding="utf-8"?>
 <p1510:revInfo xmlns:a="http://schemas.openxmlformats.org/drawingml/2006/main" xmlns:r="http://schemas.openxmlformats.org/officeDocument/2006/relationships" xmlns:p1510="http://schemas.microsoft.com/office/powerpoint/2015/10/main">
   <p1510:revLst>
-    <p1510:client id="{09B3EFAB-595D-413A-BCE6-1C0868C96490}" v="12" dt="2026-08-11T20:27:31.717"/>
+    <p1510:client id="{09B3EFAB-595D-413A-BCE6-1C0868C96490}" v="18" dt="2026-08-13T18:59:05.974"/>
   </p1510:revLst>
 </p1510:revInfo>
 </file>
@@ -132,13 +132,13 @@
 <pc:chgInfo xmlns:a="http://schemas.openxmlformats.org/drawingml/2006/main" xmlns:r="http://schemas.openxmlformats.org/officeDocument/2006/relationships" xmlns:ac="http://schemas.microsoft.com/office/drawing/2013/main/command" xmlns:pc="http://schemas.microsoft.com/office/powerpoint/2013/main/command">
   <pc:docChgLst>
     <pc:chgData name="Bourama Aya" userId="bc3cf622bba950c8" providerId="LiveId" clId="{80D05DEE-435E-45B8-940D-BDCD6398AD36}"/>
-    <pc:docChg chg="modSld">
-      <pc:chgData name="Bourama Aya" userId="bc3cf622bba950c8" providerId="LiveId" clId="{80D05DEE-435E-45B8-940D-BDCD6398AD36}" dt="2026-08-11T20:28:49.572" v="53"/>
+    <pc:docChg chg="custSel modSld">
+      <pc:chgData name="Bourama Aya" userId="bc3cf622bba950c8" providerId="LiveId" clId="{80D05DEE-435E-45B8-940D-BDCD6398AD36}" dt="2026-08-13T19:08:58.504" v="125" actId="14100"/>
       <pc:docMkLst>
         <pc:docMk/>
       </pc:docMkLst>
       <pc:sldChg chg="addSp delSp modSp mod">
-        <pc:chgData name="Bourama Aya" userId="bc3cf622bba950c8" providerId="LiveId" clId="{80D05DEE-435E-45B8-940D-BDCD6398AD36}" dt="2026-08-11T20:28:49.572" v="53"/>
+        <pc:chgData name="Bourama Aya" userId="bc3cf622bba950c8" providerId="LiveId" clId="{80D05DEE-435E-45B8-940D-BDCD6398AD36}" dt="2026-08-13T19:08:58.504" v="125" actId="14100"/>
         <pc:sldMkLst>
           <pc:docMk/>
           <pc:sldMk cId="0" sldId="256"/>
@@ -151,20 +151,28 @@
             <ac:spMk id="2" creationId="{00000000-0000-0000-0000-000000000000}"/>
           </ac:spMkLst>
         </pc:spChg>
-        <pc:spChg chg="add del mod">
-          <ac:chgData name="Bourama Aya" userId="bc3cf622bba950c8" providerId="LiveId" clId="{80D05DEE-435E-45B8-940D-BDCD6398AD36}" dt="2026-08-11T20:28:49.572" v="53"/>
-          <ac:spMkLst>
-            <pc:docMk/>
-            <pc:sldMk cId="0" sldId="256"/>
-            <ac:spMk id="5" creationId="{12430DC6-C0F6-25FD-44AA-2111B3EFCDB1}"/>
-          </ac:spMkLst>
-        </pc:spChg>
         <pc:spChg chg="mod">
           <ac:chgData name="Bourama Aya" userId="bc3cf622bba950c8" providerId="LiveId" clId="{80D05DEE-435E-45B8-940D-BDCD6398AD36}" dt="2026-08-11T20:25:20.977" v="28" actId="1076"/>
           <ac:spMkLst>
             <pc:docMk/>
             <pc:sldMk cId="0" sldId="256"/>
             <ac:spMk id="10" creationId="{00000000-0000-0000-0000-000000000000}"/>
+          </ac:spMkLst>
+        </pc:spChg>
+        <pc:spChg chg="mod">
+          <ac:chgData name="Bourama Aya" userId="bc3cf622bba950c8" providerId="LiveId" clId="{80D05DEE-435E-45B8-940D-BDCD6398AD36}" dt="2026-08-13T19:08:21.519" v="122" actId="20577"/>
+          <ac:spMkLst>
+            <pc:docMk/>
+            <pc:sldMk cId="0" sldId="256"/>
+            <ac:spMk id="12" creationId="{00000000-0000-0000-0000-000000000000}"/>
+          </ac:spMkLst>
+        </pc:spChg>
+        <pc:spChg chg="mod">
+          <ac:chgData name="Bourama Aya" userId="bc3cf622bba950c8" providerId="LiveId" clId="{80D05DEE-435E-45B8-940D-BDCD6398AD36}" dt="2026-08-13T19:08:43.521" v="124" actId="255"/>
+          <ac:spMkLst>
+            <pc:docMk/>
+            <pc:sldMk cId="0" sldId="256"/>
+            <ac:spMk id="13" creationId="{00000000-0000-0000-0000-000000000000}"/>
           </ac:spMkLst>
         </pc:spChg>
         <pc:spChg chg="mod">
@@ -200,14 +208,6 @@
           </ac:spMkLst>
         </pc:spChg>
         <pc:spChg chg="mod">
-          <ac:chgData name="Bourama Aya" userId="bc3cf622bba950c8" providerId="LiveId" clId="{80D05DEE-435E-45B8-940D-BDCD6398AD36}" dt="2026-08-11T18:31:18.123" v="12" actId="1076"/>
-          <ac:spMkLst>
-            <pc:docMk/>
-            <pc:sldMk cId="0" sldId="256"/>
-            <ac:spMk id="22" creationId="{00000000-0000-0000-0000-000000000000}"/>
-          </ac:spMkLst>
-        </pc:spChg>
-        <pc:spChg chg="mod">
           <ac:chgData name="Bourama Aya" userId="bc3cf622bba950c8" providerId="LiveId" clId="{80D05DEE-435E-45B8-940D-BDCD6398AD36}" dt="2026-08-11T20:26:48.134" v="39" actId="1076"/>
           <ac:spMkLst>
             <pc:docMk/>
@@ -223,12 +223,20 @@
             <ac:picMk id="3" creationId="{00000000-0000-0000-0000-000000000000}"/>
           </ac:picMkLst>
         </pc:picChg>
-        <pc:picChg chg="mod">
-          <ac:chgData name="Bourama Aya" userId="bc3cf622bba950c8" providerId="LiveId" clId="{80D05DEE-435E-45B8-940D-BDCD6398AD36}" dt="2026-08-11T20:26:51.119" v="40" actId="1076"/>
+        <pc:picChg chg="del mod">
+          <ac:chgData name="Bourama Aya" userId="bc3cf622bba950c8" providerId="LiveId" clId="{80D05DEE-435E-45B8-940D-BDCD6398AD36}" dt="2026-08-13T19:00:18.682" v="60" actId="478"/>
           <ac:picMkLst>
             <pc:docMk/>
             <pc:sldMk cId="0" sldId="256"/>
             <ac:picMk id="4" creationId="{00000000-0000-0000-0000-000000000000}"/>
+          </ac:picMkLst>
+        </pc:picChg>
+        <pc:picChg chg="add mod">
+          <ac:chgData name="Bourama Aya" userId="bc3cf622bba950c8" providerId="LiveId" clId="{80D05DEE-435E-45B8-940D-BDCD6398AD36}" dt="2026-08-13T19:08:58.504" v="125" actId="14100"/>
+          <ac:picMkLst>
+            <pc:docMk/>
+            <pc:sldMk cId="0" sldId="256"/>
+            <ac:picMk id="6" creationId="{E389DA65-B893-36F7-917C-05C25E399596}"/>
           </ac:picMkLst>
         </pc:picChg>
         <pc:picChg chg="mod">
@@ -276,7 +284,7 @@
         </pc:sldMkLst>
       </pc:sldChg>
       <pc:sldChg chg="modTransition">
-        <pc:chgData name="Bourama Aya" userId="bc3cf622bba950c8" providerId="LiveId" clId="{80D05DEE-435E-45B8-940D-BDCD6398AD36}" dt="2026-08-11T20:23:57.272" v="24"/>
+        <pc:chgData name="Bourama Aya" userId="bc3cf622bba950c8" providerId="LiveId" clId="{80D05DEE-435E-45B8-940D-BDCD6398AD36}" dt="2026-08-13T18:59:05.972" v="59"/>
         <pc:sldMkLst>
           <pc:docMk/>
           <pc:sldMk cId="0" sldId="263"/>
@@ -1257,7 +1265,7 @@
           </a:prstGeom>
           <a:extLst>
             <a:ext uri="{C572A759-6A51-4108-AA02-DFA0A04FC94B}">
-              <ma14:wrappingTextBoxFlag xmlns="" xmlns:ma14="http://schemas.microsoft.com/office/mac/drawingml/2011/main" val="0"/>
+              <ma14:wrappingTextBoxFlag xmlns:ma14="http://schemas.microsoft.com/office/mac/drawingml/2011/main" xmlns="" val="0"/>
             </a:ext>
           </a:extLst>
         </p:spPr>
@@ -1276,7 +1284,7 @@
             <a:pPr algn="l"/>
             <a:fld id="{F7021451-1387-4CA6-816F-3879F97B5CBC}" type="slidenum">
               <a:rPr lang="en-US" b="0"/>
-              <a:t>‹N°›</a:t>
+              <a:t>‹#›</a:t>
             </a:fld>
             <a:endParaRPr lang="en-US"/>
           </a:p>
@@ -1332,7 +1340,7 @@
           </a:prstGeom>
           <a:extLst>
             <a:ext uri="{C572A759-6A51-4108-AA02-DFA0A04FC94B}">
-              <ma14:wrappingTextBoxFlag xmlns="" xmlns:ma14="http://schemas.microsoft.com/office/mac/drawingml/2011/main" val="0"/>
+              <ma14:wrappingTextBoxFlag xmlns:ma14="http://schemas.microsoft.com/office/mac/drawingml/2011/main" xmlns="" val="0"/>
             </a:ext>
           </a:extLst>
         </p:spPr>
@@ -1351,7 +1359,7 @@
             <a:pPr algn="l"/>
             <a:fld id="{F7021451-1387-4CA6-816F-3879F97B5CBC}" type="slidenum">
               <a:rPr lang="en-US" b="0"/>
-              <a:t>‹N°›</a:t>
+              <a:t>‹#›</a:t>
             </a:fld>
             <a:endParaRPr lang="en-US"/>
           </a:p>
@@ -1684,7 +1692,7 @@
           </a:bodyPr>
           <a:lstStyle/>
           <a:p>
-            <a:endParaRPr lang="fr-FR" sz="1800" b="0" strike="noStrike" spc="-1">
+            <a:endParaRPr lang="fr-FR" sz="1800" b="0" strike="noStrike" spc="-1" dirty="0">
               <a:solidFill>
                 <a:srgbClr val="FFFFFF"/>
               </a:solidFill>
@@ -1869,15 +1877,24 @@
               </a:tabLst>
             </a:pPr>
             <a:r>
-              <a:rPr lang="en-US" sz="1600" b="1" strike="noStrike" spc="-1" dirty="0">
+              <a:rPr lang="en-US" sz="3600" b="1" spc="-1" dirty="0">
                 <a:solidFill>
                   <a:srgbClr val="06B6D4"/>
                 </a:solidFill>
                 <a:latin typeface="Calibri"/>
               </a:rPr>
-              <a:t>PROJET DE FIN DE CYCLE</a:t>
+              <a:t>PROJET DE FIN </a:t>
             </a:r>
-            <a:endParaRPr lang="fr-FR" sz="1600" b="0" strike="noStrike" spc="-1" dirty="0">
+            <a:r>
+              <a:rPr lang="en-US" sz="3600" b="1" strike="noStrike" spc="-1" dirty="0">
+                <a:solidFill>
+                  <a:srgbClr val="06B6D4"/>
+                </a:solidFill>
+                <a:latin typeface="Calibri"/>
+              </a:rPr>
+              <a:t>DE CYCLE</a:t>
+            </a:r>
+            <a:endParaRPr lang="fr-FR" sz="3600" b="0" strike="noStrike" spc="-1" dirty="0">
               <a:solidFill>
                 <a:srgbClr val="FFFFFF"/>
               </a:solidFill>
@@ -1894,8 +1911,8 @@
         </p:nvSpPr>
         <p:spPr>
           <a:xfrm>
-            <a:off x="281877" y="1798037"/>
-            <a:ext cx="10332360" cy="1096920"/>
+            <a:off x="726831" y="1798037"/>
+            <a:ext cx="9887406" cy="1096920"/>
           </a:xfrm>
           <a:prstGeom prst="rect">
             <a:avLst/>
@@ -1932,7 +1949,7 @@
               </a:tabLst>
             </a:pPr>
             <a:r>
-              <a:rPr lang="en-US" sz="7200" b="1" strike="noStrike" spc="-1" dirty="0" err="1">
+              <a:rPr lang="en-US" sz="5400" b="1" strike="noStrike" spc="-1" dirty="0" err="1">
                 <a:solidFill>
                   <a:srgbClr val="FFFFFF"/>
                 </a:solidFill>
@@ -1940,7 +1957,7 @@
               </a:rPr>
               <a:t>EduTrack</a:t>
             </a:r>
-            <a:endParaRPr lang="fr-FR" sz="7200" b="0" strike="noStrike" spc="-1" dirty="0">
+            <a:endParaRPr lang="fr-FR" sz="5400" b="0" strike="noStrike" spc="-1" dirty="0">
               <a:solidFill>
                 <a:srgbClr val="FFFFFF"/>
               </a:solidFill>
@@ -2628,25 +2645,32 @@
       </p:sp>
       <p:pic>
         <p:nvPicPr>
-          <p:cNvPr id="4" name="Image 2" descr="MEMOIRE/Capture d'ecran application web et mobile/Screenshot_20260702_213134_mobile-ionic.jpg"/>
-          <p:cNvPicPr/>
+          <p:cNvPr id="6" name="Picture 5">
+            <a:extLst>
+              <a:ext uri="{FF2B5EF4-FFF2-40B4-BE49-F238E27FC236}">
+                <a16:creationId xmlns:a16="http://schemas.microsoft.com/office/drawing/2014/main" id="{E389DA65-B893-36F7-917C-05C25E399596}"/>
+              </a:ext>
+            </a:extLst>
+          </p:cNvPr>
+          <p:cNvPicPr>
+            <a:picLocks noChangeAspect="1"/>
+          </p:cNvPicPr>
           <p:nvPr/>
         </p:nvPicPr>
         <p:blipFill>
           <a:blip r:embed="rId5"/>
-          <a:stretch/>
+          <a:stretch>
+            <a:fillRect/>
+          </a:stretch>
         </p:blipFill>
         <p:spPr>
           <a:xfrm>
-            <a:off x="10166839" y="1962131"/>
-            <a:ext cx="1554120" cy="3474360"/>
-          </a:xfrm>
-          <a:prstGeom prst="rect">
-            <a:avLst/>
-          </a:prstGeom>
-          <a:ln w="0">
-            <a:noFill/>
-          </a:ln>
+            <a:off x="10111654" y="1874456"/>
+            <a:ext cx="1664490" cy="3571706"/>
+          </a:xfrm>
+          <a:prstGeom prst="rect">
+            <a:avLst/>
+          </a:prstGeom>
         </p:spPr>
       </p:pic>
     </p:spTree>
@@ -3116,10 +3140,10 @@
           <p:nvPr/>
         </p:nvPicPr>
         <p:blipFill>
-          <a:blip r:embed="rId4">
+          <a:blip>
             <a:extLst>
               <a:ext uri="{96DAC541-7B7A-43D3-8B79-37D633B846F1}">
-                <asvg:svgBlip xmlns:asvg="http://schemas.microsoft.com/office/drawing/2016/SVG/main" r:embed="rId5"/>
+                <asvg:svgBlip xmlns:asvg="http://schemas.microsoft.com/office/drawing/2016/SVG/main" r:embed="rId4"/>
               </a:ext>
             </a:extLst>
           </a:blip>
@@ -3257,10 +3281,10 @@
           <p:nvPr/>
         </p:nvPicPr>
         <p:blipFill>
-          <a:blip r:embed="rId6">
+          <a:blip>
             <a:extLst>
               <a:ext uri="{96DAC541-7B7A-43D3-8B79-37D633B846F1}">
-                <asvg:svgBlip xmlns:asvg="http://schemas.microsoft.com/office/drawing/2016/SVG/main" r:embed="rId7"/>
+                <asvg:svgBlip xmlns:asvg="http://schemas.microsoft.com/office/drawing/2016/SVG/main" r:embed="rId5"/>
               </a:ext>
             </a:extLst>
           </a:blip>
@@ -3398,10 +3422,10 @@
           <p:nvPr/>
         </p:nvPicPr>
         <p:blipFill>
-          <a:blip r:embed="rId8">
+          <a:blip>
             <a:extLst>
               <a:ext uri="{96DAC541-7B7A-43D3-8B79-37D633B846F1}">
-                <asvg:svgBlip xmlns:asvg="http://schemas.microsoft.com/office/drawing/2016/SVG/main" r:embed="rId9"/>
+                <asvg:svgBlip xmlns:asvg="http://schemas.microsoft.com/office/drawing/2016/SVG/main" r:embed="rId6"/>
               </a:ext>
             </a:extLst>
           </a:blip>
@@ -3582,7 +3606,7 @@
           <p:nvPr/>
         </p:nvPicPr>
         <p:blipFill>
-          <a:blip r:embed="rId10"/>
+          <a:blip r:embed="rId7"/>
           <a:stretch>
             <a:fillRect/>
           </a:stretch>
@@ -3718,7 +3742,7 @@
           <p:nvPr/>
         </p:nvPicPr>
         <p:blipFill>
-          <a:blip r:embed="rId11"/>
+          <a:blip r:embed="rId8"/>
           <a:stretch>
             <a:fillRect/>
           </a:stretch>
@@ -3854,7 +3878,7 @@
           <p:nvPr/>
         </p:nvPicPr>
         <p:blipFill>
-          <a:blip r:embed="rId12"/>
+          <a:blip r:embed="rId9"/>
           <a:stretch>
             <a:fillRect/>
           </a:stretch>
@@ -3944,7 +3968,7 @@
           <p:nvPr/>
         </p:nvPicPr>
         <p:blipFill>
-          <a:blip r:embed="rId13"/>
+          <a:blip r:embed="rId10"/>
           <a:stretch>
             <a:fillRect/>
           </a:stretch>
@@ -4474,10 +4498,10 @@
           <p:nvPr/>
         </p:nvPicPr>
         <p:blipFill>
-          <a:blip r:embed="rId5">
+          <a:blip>
             <a:extLst>
               <a:ext uri="{96DAC541-7B7A-43D3-8B79-37D633B846F1}">
-                <asvg:svgBlip xmlns:asvg="http://schemas.microsoft.com/office/drawing/2016/SVG/main" r:embed="rId6"/>
+                <asvg:svgBlip xmlns:asvg="http://schemas.microsoft.com/office/drawing/2016/SVG/main" r:embed="rId5"/>
               </a:ext>
             </a:extLst>
           </a:blip>
@@ -4615,10 +4639,10 @@
           <p:nvPr/>
         </p:nvPicPr>
         <p:blipFill>
-          <a:blip r:embed="rId7">
+          <a:blip>
             <a:extLst>
               <a:ext uri="{96DAC541-7B7A-43D3-8B79-37D633B846F1}">
-                <asvg:svgBlip xmlns:asvg="http://schemas.microsoft.com/office/drawing/2016/SVG/main" r:embed="rId8"/>
+                <asvg:svgBlip xmlns:asvg="http://schemas.microsoft.com/office/drawing/2016/SVG/main" r:embed="rId6"/>
               </a:ext>
             </a:extLst>
           </a:blip>
@@ -4868,10 +4892,10 @@
           <p:nvPr/>
         </p:nvPicPr>
         <p:blipFill>
-          <a:blip r:embed="rId9">
+          <a:blip>
             <a:extLst>
               <a:ext uri="{96DAC541-7B7A-43D3-8B79-37D633B846F1}">
-                <asvg:svgBlip xmlns:asvg="http://schemas.microsoft.com/office/drawing/2016/SVG/main" r:embed="rId10"/>
+                <asvg:svgBlip xmlns:asvg="http://schemas.microsoft.com/office/drawing/2016/SVG/main" r:embed="rId7"/>
               </a:ext>
             </a:extLst>
           </a:blip>
@@ -5045,7 +5069,7 @@
           <p:nvPr/>
         </p:nvPicPr>
         <p:blipFill>
-          <a:blip r:embed="rId11"/>
+          <a:blip r:embed="rId8"/>
           <a:stretch>
             <a:fillRect/>
           </a:stretch>
@@ -5967,10 +5991,10 @@
           <p:nvPr/>
         </p:nvPicPr>
         <p:blipFill>
-          <a:blip r:embed="rId4">
+          <a:blip>
             <a:extLst>
               <a:ext uri="{96DAC541-7B7A-43D3-8B79-37D633B846F1}">
-                <asvg:svgBlip xmlns:asvg="http://schemas.microsoft.com/office/drawing/2016/SVG/main" r:embed="rId5"/>
+                <asvg:svgBlip xmlns:asvg="http://schemas.microsoft.com/office/drawing/2016/SVG/main" r:embed="rId4"/>
               </a:ext>
             </a:extLst>
           </a:blip>
@@ -6436,10 +6460,10 @@
           <p:nvPr/>
         </p:nvPicPr>
         <p:blipFill>
-          <a:blip r:embed="rId6">
+          <a:blip>
             <a:extLst>
               <a:ext uri="{96DAC541-7B7A-43D3-8B79-37D633B846F1}">
-                <asvg:svgBlip xmlns:asvg="http://schemas.microsoft.com/office/drawing/2016/SVG/main" r:embed="rId7"/>
+                <asvg:svgBlip xmlns:asvg="http://schemas.microsoft.com/office/drawing/2016/SVG/main" r:embed="rId5"/>
               </a:ext>
             </a:extLst>
           </a:blip>
@@ -6615,7 +6639,7 @@
           <p:nvPr/>
         </p:nvPicPr>
         <p:blipFill>
-          <a:blip r:embed="rId8"/>
+          <a:blip r:embed="rId6"/>
           <a:stretch>
             <a:fillRect/>
           </a:stretch>
@@ -6639,7 +6663,7 @@
           <p:nvPr/>
         </p:nvPicPr>
         <p:blipFill>
-          <a:blip r:embed="rId9"/>
+          <a:blip r:embed="rId7"/>
           <a:stretch>
             <a:fillRect/>
           </a:stretch>
@@ -6663,7 +6687,7 @@
           <p:nvPr/>
         </p:nvPicPr>
         <p:blipFill>
-          <a:blip r:embed="rId10"/>
+          <a:blip r:embed="rId8"/>
           <a:stretch>
             <a:fillRect/>
           </a:stretch>
@@ -8683,10 +8707,10 @@
           <p:nvPr/>
         </p:nvPicPr>
         <p:blipFill>
-          <a:blip r:embed="rId4">
+          <a:blip>
             <a:extLst>
               <a:ext uri="{96DAC541-7B7A-43D3-8B79-37D633B846F1}">
-                <asvg:svgBlip xmlns:asvg="http://schemas.microsoft.com/office/drawing/2016/SVG/main" r:embed="rId5"/>
+                <asvg:svgBlip xmlns:asvg="http://schemas.microsoft.com/office/drawing/2016/SVG/main" r:embed="rId4"/>
               </a:ext>
             </a:extLst>
           </a:blip>
@@ -8719,10 +8743,10 @@
           <p:nvPr/>
         </p:nvPicPr>
         <p:blipFill>
-          <a:blip r:embed="rId6">
+          <a:blip>
             <a:extLst>
               <a:ext uri="{96DAC541-7B7A-43D3-8B79-37D633B846F1}">
-                <asvg:svgBlip xmlns:asvg="http://schemas.microsoft.com/office/drawing/2016/SVG/main" r:embed="rId7"/>
+                <asvg:svgBlip xmlns:asvg="http://schemas.microsoft.com/office/drawing/2016/SVG/main" r:embed="rId5"/>
               </a:ext>
             </a:extLst>
           </a:blip>
@@ -8991,10 +9015,10 @@
           <p:nvPr/>
         </p:nvPicPr>
         <p:blipFill>
-          <a:blip r:embed="rId8">
+          <a:blip>
             <a:extLst>
               <a:ext uri="{96DAC541-7B7A-43D3-8B79-37D633B846F1}">
-                <asvg:svgBlip xmlns:asvg="http://schemas.microsoft.com/office/drawing/2016/SVG/main" r:embed="rId9"/>
+                <asvg:svgBlip xmlns:asvg="http://schemas.microsoft.com/office/drawing/2016/SVG/main" r:embed="rId6"/>
               </a:ext>
             </a:extLst>
           </a:blip>
@@ -9361,10 +9385,10 @@
           <p:nvPr/>
         </p:nvPicPr>
         <p:blipFill>
-          <a:blip r:embed="rId10">
+          <a:blip>
             <a:extLst>
               <a:ext uri="{96DAC541-7B7A-43D3-8B79-37D633B846F1}">
-                <asvg:svgBlip xmlns:asvg="http://schemas.microsoft.com/office/drawing/2016/SVG/main" r:embed="rId11"/>
+                <asvg:svgBlip xmlns:asvg="http://schemas.microsoft.com/office/drawing/2016/SVG/main" r:embed="rId7"/>
               </a:ext>
             </a:extLst>
           </a:blip>
@@ -10250,10 +10274,10 @@
           <p:nvPr/>
         </p:nvPicPr>
         <p:blipFill>
-          <a:blip r:embed="rId4">
+          <a:blip>
             <a:extLst>
               <a:ext uri="{96DAC541-7B7A-43D3-8B79-37D633B846F1}">
-                <asvg:svgBlip xmlns:asvg="http://schemas.microsoft.com/office/drawing/2016/SVG/main" r:embed="rId5"/>
+                <asvg:svgBlip xmlns:asvg="http://schemas.microsoft.com/office/drawing/2016/SVG/main" r:embed="rId4"/>
               </a:ext>
             </a:extLst>
           </a:blip>
@@ -10353,10 +10377,10 @@
           <p:nvPr/>
         </p:nvPicPr>
         <p:blipFill>
-          <a:blip r:embed="rId6">
+          <a:blip>
             <a:extLst>
               <a:ext uri="{96DAC541-7B7A-43D3-8B79-37D633B846F1}">
-                <asvg:svgBlip xmlns:asvg="http://schemas.microsoft.com/office/drawing/2016/SVG/main" r:embed="rId7"/>
+                <asvg:svgBlip xmlns:asvg="http://schemas.microsoft.com/office/drawing/2016/SVG/main" r:embed="rId5"/>
               </a:ext>
             </a:extLst>
           </a:blip>
@@ -10456,10 +10480,10 @@
           <p:nvPr/>
         </p:nvPicPr>
         <p:blipFill>
-          <a:blip r:embed="rId8">
+          <a:blip>
             <a:extLst>
               <a:ext uri="{96DAC541-7B7A-43D3-8B79-37D633B846F1}">
-                <asvg:svgBlip xmlns:asvg="http://schemas.microsoft.com/office/drawing/2016/SVG/main" r:embed="rId9"/>
+                <asvg:svgBlip xmlns:asvg="http://schemas.microsoft.com/office/drawing/2016/SVG/main" r:embed="rId6"/>
               </a:ext>
             </a:extLst>
           </a:blip>
@@ -10633,10 +10657,10 @@
           <p:nvPr/>
         </p:nvPicPr>
         <p:blipFill>
-          <a:blip r:embed="rId10">
+          <a:blip>
             <a:extLst>
               <a:ext uri="{96DAC541-7B7A-43D3-8B79-37D633B846F1}">
-                <asvg:svgBlip xmlns:asvg="http://schemas.microsoft.com/office/drawing/2016/SVG/main" r:embed="rId11"/>
+                <asvg:svgBlip xmlns:asvg="http://schemas.microsoft.com/office/drawing/2016/SVG/main" r:embed="rId7"/>
               </a:ext>
             </a:extLst>
           </a:blip>
@@ -10736,10 +10760,10 @@
           <p:nvPr/>
         </p:nvPicPr>
         <p:blipFill>
-          <a:blip r:embed="rId12">
+          <a:blip>
             <a:extLst>
               <a:ext uri="{96DAC541-7B7A-43D3-8B79-37D633B846F1}">
-                <asvg:svgBlip xmlns:asvg="http://schemas.microsoft.com/office/drawing/2016/SVG/main" r:embed="rId13"/>
+                <asvg:svgBlip xmlns:asvg="http://schemas.microsoft.com/office/drawing/2016/SVG/main" r:embed="rId8"/>
               </a:ext>
             </a:extLst>
           </a:blip>
@@ -10913,10 +10937,10 @@
           <p:nvPr/>
         </p:nvPicPr>
         <p:blipFill>
-          <a:blip r:embed="rId14">
+          <a:blip>
             <a:extLst>
               <a:ext uri="{96DAC541-7B7A-43D3-8B79-37D633B846F1}">
-                <asvg:svgBlip xmlns:asvg="http://schemas.microsoft.com/office/drawing/2016/SVG/main" r:embed="rId15"/>
+                <asvg:svgBlip xmlns:asvg="http://schemas.microsoft.com/office/drawing/2016/SVG/main" r:embed="rId9"/>
               </a:ext>
             </a:extLst>
           </a:blip>
@@ -11016,10 +11040,10 @@
           <p:nvPr/>
         </p:nvPicPr>
         <p:blipFill>
-          <a:blip r:embed="rId16">
+          <a:blip>
             <a:extLst>
               <a:ext uri="{96DAC541-7B7A-43D3-8B79-37D633B846F1}">
-                <asvg:svgBlip xmlns:asvg="http://schemas.microsoft.com/office/drawing/2016/SVG/main" r:embed="rId17"/>
+                <asvg:svgBlip xmlns:asvg="http://schemas.microsoft.com/office/drawing/2016/SVG/main" r:embed="rId10"/>
               </a:ext>
             </a:extLst>
           </a:blip>
@@ -11119,10 +11143,10 @@
           <p:nvPr/>
         </p:nvPicPr>
         <p:blipFill>
-          <a:blip r:embed="rId18">
+          <a:blip>
             <a:extLst>
               <a:ext uri="{96DAC541-7B7A-43D3-8B79-37D633B846F1}">
-                <asvg:svgBlip xmlns:asvg="http://schemas.microsoft.com/office/drawing/2016/SVG/main" r:embed="rId19"/>
+                <asvg:svgBlip xmlns:asvg="http://schemas.microsoft.com/office/drawing/2016/SVG/main" r:embed="rId11"/>
               </a:ext>
             </a:extLst>
           </a:blip>
@@ -11222,10 +11246,10 @@
           <p:nvPr/>
         </p:nvPicPr>
         <p:blipFill>
-          <a:blip r:embed="rId20">
+          <a:blip>
             <a:extLst>
               <a:ext uri="{96DAC541-7B7A-43D3-8B79-37D633B846F1}">
-                <asvg:svgBlip xmlns:asvg="http://schemas.microsoft.com/office/drawing/2016/SVG/main" r:embed="rId21"/>
+                <asvg:svgBlip xmlns:asvg="http://schemas.microsoft.com/office/drawing/2016/SVG/main" r:embed="rId12"/>
               </a:ext>
             </a:extLst>
           </a:blip>
@@ -15127,9 +15151,18 @@
   <p:clrMapOvr>
     <a:masterClrMapping/>
   </p:clrMapOvr>
-  <p:transition>
-    <p:fade thruBlk="1"/>
-  </p:transition>
+  <mc:AlternateContent xmlns:mc="http://schemas.openxmlformats.org/markup-compatibility/2006">
+    <mc:Choice xmlns:p14="http://schemas.microsoft.com/office/powerpoint/2010/main" Requires="p14">
+      <p:transition spd="slow" p14:dur="1600">
+        <p:blinds dir="vert"/>
+      </p:transition>
+    </mc:Choice>
+    <mc:Fallback>
+      <p:transition spd="slow">
+        <p:blinds dir="vert"/>
+      </p:transition>
+    </mc:Fallback>
+  </mc:AlternateContent>
 </p:sld>
 </file>
 
@@ -15572,10 +15605,10 @@
           <p:nvPr/>
         </p:nvPicPr>
         <p:blipFill>
-          <a:blip r:embed="rId4">
+          <a:blip>
             <a:extLst>
               <a:ext uri="{96DAC541-7B7A-43D3-8B79-37D633B846F1}">
-                <asvg:svgBlip xmlns:asvg="http://schemas.microsoft.com/office/drawing/2016/SVG/main" r:embed="rId5"/>
+                <asvg:svgBlip xmlns:asvg="http://schemas.microsoft.com/office/drawing/2016/SVG/main" r:embed="rId4"/>
               </a:ext>
             </a:extLst>
           </a:blip>
@@ -15713,10 +15746,10 @@
           <p:nvPr/>
         </p:nvPicPr>
         <p:blipFill>
-          <a:blip r:embed="rId6">
+          <a:blip>
             <a:extLst>
               <a:ext uri="{96DAC541-7B7A-43D3-8B79-37D633B846F1}">
-                <asvg:svgBlip xmlns:asvg="http://schemas.microsoft.com/office/drawing/2016/SVG/main" r:embed="rId7"/>
+                <asvg:svgBlip xmlns:asvg="http://schemas.microsoft.com/office/drawing/2016/SVG/main" r:embed="rId5"/>
               </a:ext>
             </a:extLst>
           </a:blip>
@@ -16034,10 +16067,10 @@
           <p:nvPr/>
         </p:nvPicPr>
         <p:blipFill>
-          <a:blip r:embed="rId8">
+          <a:blip>
             <a:extLst>
               <a:ext uri="{96DAC541-7B7A-43D3-8B79-37D633B846F1}">
-                <asvg:svgBlip xmlns:asvg="http://schemas.microsoft.com/office/drawing/2016/SVG/main" r:embed="rId9"/>
+                <asvg:svgBlip xmlns:asvg="http://schemas.microsoft.com/office/drawing/2016/SVG/main" r:embed="rId6"/>
               </a:ext>
             </a:extLst>
           </a:blip>
@@ -16175,10 +16208,10 @@
           <p:nvPr/>
         </p:nvPicPr>
         <p:blipFill>
-          <a:blip r:embed="rId10">
+          <a:blip>
             <a:extLst>
               <a:ext uri="{96DAC541-7B7A-43D3-8B79-37D633B846F1}">
-                <asvg:svgBlip xmlns:asvg="http://schemas.microsoft.com/office/drawing/2016/SVG/main" r:embed="rId11"/>
+                <asvg:svgBlip xmlns:asvg="http://schemas.microsoft.com/office/drawing/2016/SVG/main" r:embed="rId7"/>
               </a:ext>
             </a:extLst>
           </a:blip>
@@ -16316,10 +16349,10 @@
           <p:nvPr/>
         </p:nvPicPr>
         <p:blipFill>
-          <a:blip r:embed="rId12">
+          <a:blip>
             <a:extLst>
               <a:ext uri="{96DAC541-7B7A-43D3-8B79-37D633B846F1}">
-                <asvg:svgBlip xmlns:asvg="http://schemas.microsoft.com/office/drawing/2016/SVG/main" r:embed="rId13"/>
+                <asvg:svgBlip xmlns:asvg="http://schemas.microsoft.com/office/drawing/2016/SVG/main" r:embed="rId8"/>
               </a:ext>
             </a:extLst>
           </a:blip>
@@ -16533,7 +16566,7 @@
           <p:nvPr/>
         </p:nvPicPr>
         <p:blipFill>
-          <a:blip r:embed="rId14"/>
+          <a:blip r:embed="rId9"/>
           <a:stretch>
             <a:fillRect/>
           </a:stretch>
@@ -16557,7 +16590,7 @@
           <p:nvPr/>
         </p:nvPicPr>
         <p:blipFill>
-          <a:blip r:embed="rId15"/>
+          <a:blip r:embed="rId10"/>
           <a:stretch>
             <a:fillRect/>
           </a:stretch>
@@ -20124,13 +20157,13 @@
   <p:clrMapOvr>
     <a:masterClrMapping/>
   </p:clrMapOvr>
-  <mc:AlternateContent xmlns:mc="http://schemas.openxmlformats.org/markup-compatibility/2006">
-    <mc:Choice xmlns:p14="http://schemas.microsoft.com/office/powerpoint/2010/main" Requires="p14">
+  <mc:AlternateContent xmlns:mc="http://schemas.openxmlformats.org/markup-compatibility/2006" xmlns:p14="http://schemas.microsoft.com/office/powerpoint/2010/main">
+    <mc:Choice Requires="p14">
       <p:transition spd="med" p14:dur="600">
         <p:fade thruBlk="1"/>
       </p:transition>
     </mc:Choice>
-    <mc:Fallback>
+    <mc:Fallback xmlns="">
       <p:transition spd="med">
         <p:fade thruBlk="1"/>
       </p:transition>

</xml_diff>